<commit_message>
Show the steering result on slide 5, not just its cost
The task asks for the multi-probe steering experiment evaluated on held-out
data. Slide 5 asserted the numbers in its stat chips but showed only the
cross-variable leakage matrix -- the K-versus-accuracy curve those numbers come
from was never displayed.

New figure steering_combined.png puts the three panels together, which is the
whole trade-off in one place:

  left    steering accuracy against K, read by a held-out probe, as a
          percentage of the floor-to-ceiling gap closed
  middle  the cross-variable leakage matrix at subspace dimension 8
  right   leakage against subspace dimension

Slide 5 retitled "Steering direction needs a coordinated subspace"; the dek now
names the held-out-probe protocol explicitly, and the chips contrast direction
at K=1 (28%) against either scalar at K=1 (74%) rather than repeating two
leakage figures. Speaker notes spell out the three held-out axes and the
Moore-Penrose objective.
</commit_message>
<xml_diff>
--- a/artifacts/deck/vjepa-direction-ring.pptx
+++ b/artifacts/deck/vjepa-direction-ring.pptx
@@ -1141,19 +1141,37 @@
           <a:lstStyle/>
           <a:p>
             <a:r>
-              <a:t>First the control result: a single probe closes 28% of the gap for direction but 74% for either scalar. Direction needs K of at least 2 and is solved by K around 4 — the causal echo of slide 3.</a:t>
+              <a:t>This is the paper's steering experiment, and the evaluation protocol is the part worth spelling out.</a:t>
             </a:r>
           </a:p>
           <a:p/>
           <a:p>
             <a:r>
-              <a:t>Then the cost. To build a subspace big enough to steer the ring, you capture other kinematics with it. By dimension 16 EVERY cell in the matrix leaks. Dimension 4 to 8 is the usable operating point.</a:t>
+              <a:t>THREE INDEPENDENT HELD-OUT AXES. The evaluation probe is never one of the K that built the steering subspace, and it is fitted on clips disjoint from all of them. The clips being steered carry target values never seen during fitting. Without the probe split, 'steering worked' would only mean the intervention satisfied the very equations it solved.</a:t>
             </a:r>
           </a:p>
           <a:p/>
           <a:p>
             <a:r>
-              <a:t>TWO CELLS ARE BLANK, and that is a finding about the data. Speed and acceleration are mutually exclusive in every supplied dataset — no clip has both non-zero. So the coupling v = v0 + a t that would make speed-acceleration leakage interesting has been designed out of the stimulus set. Worth saying out loud rather than leaving a reader to wonder.</a:t>
+              <a:t>LEFT PANEL, the result. A single probe closes 28 percent of the floor-to-ceiling gap for direction but 74 percent for either scalar. Direction needs K of at least two and is essentially solved by K around four. That is the causal counterpart of slide 3: a 2-dimensional readout cannot be driven along a single direction.</a:t>
+            </a:r>
+          </a:p>
+          <a:p/>
+          <a:p>
+            <a:r>
+              <a:t>MIDDLE AND RIGHT, the cost. To build a subspace big enough to steer the ring you capture other kinematics with it. By dimension 16 every cell in the matrix leaks. Dimension 4 to 8 is the usable operating point.</a:t>
+            </a:r>
+          </a:p>
+          <a:p/>
+          <a:p>
+            <a:r>
+              <a:t>TWO CELLS ARE BLANK, and that is a finding about the data. Speed and acceleration are mutually exclusive in every supplied dataset — no clip has both non-zero — so the coupling v = v0 + a t that would make that leakage interesting has been designed out of the stimulus set.</a:t>
+            </a:r>
+          </a:p>
+          <a:p/>
+          <a:p>
+            <a:r>
+              <a:t>If asked what the intervention actually solves: minimise the L2 norm of delta-x subject to the probes reading the target. That is the Moore-Penrose minimum-norm edit, verified against a direct pseudo-inverse to three times ten to the minus fourteen. Smallest EUCLIDEAN step — which is exactly the setup for Act 2.</a:t>
             </a:r>
           </a:p>
         </p:txBody>
@@ -10673,13 +10691,13 @@
           <a:p>
             <a:pPr algn="l"/>
             <a:r>
-              <a:rPr sz="3100" b="1" i="0">
+              <a:rPr sz="3100" b="1">
                 <a:solidFill>
                   <a:srgbClr val="17191C"/>
                 </a:solidFill>
                 <a:latin typeface="Futura"/>
               </a:rPr>
-              <a:t>Control and specificity trade off</a:t>
+              <a:t>Steering direction needs a coordinated subspace</a:t>
             </a:r>
           </a:p>
         </p:txBody>
@@ -10712,41 +10730,17 @@
               </a:lnSpc>
             </a:pPr>
             <a:r>
-              <a:rPr sz="1200" b="0" i="0">
+              <a:rPr sz="1200" b="0">
                 <a:solidFill>
                   <a:srgbClr val="71757B"/>
                 </a:solidFill>
                 <a:latin typeface="Avenir Next"/>
               </a:rPr>
-              <a:t>Multi-probe subspace steering: stack K probe readouts, solve for the coordinates that make them all read the target. Each cell is drift in another variable, against that probe's own error on unmodified clips.</a:t>
-            </a:r>
-          </a:p>
-        </p:txBody>
-      </p:sp>
-      <p:pic>
-        <p:nvPicPr>
-          <p:cNvPr id="7" name="Picture 6" descr="leakage_matrix.png"/>
-          <p:cNvPicPr>
-            <a:picLocks noChangeAspect="1"/>
-          </p:cNvPicPr>
-          <p:nvPr/>
-        </p:nvPicPr>
-        <p:blipFill>
-          <a:blip r:embed="rId2"/>
-          <a:stretch>
-            <a:fillRect/>
-          </a:stretch>
-        </p:blipFill>
-        <p:spPr>
-          <a:xfrm>
-            <a:off x="2878277" y="2633472"/>
-            <a:ext cx="6435139" cy="2697480"/>
-          </a:xfrm>
-          <a:prstGeom prst="rect">
-            <a:avLst/>
-          </a:prstGeom>
-        </p:spPr>
-      </p:pic>
+              <a:t>Stack K probe readouts, solve for the coordinates that make them all read the target. Evaluated with a HELD-OUT probe — never one of the K that built the basis — on held-out label values.</a:t>
+            </a:r>
+          </a:p>
+        </p:txBody>
+      </p:sp>
       <p:cxnSp>
         <p:nvCxnSpPr>
           <p:cNvPr id="8" name="Connector 7"/>
@@ -10806,7 +10800,7 @@
           <a:p>
             <a:pPr algn="l"/>
             <a:r>
-              <a:rPr sz="800" b="0" i="0" spc="120">
+              <a:rPr sz="800" b="0" spc="120">
                 <a:solidFill>
                   <a:srgbClr val="71757B"/>
                 </a:solidFill>
@@ -10841,7 +10835,7 @@
           <a:p>
             <a:pPr algn="l"/>
             <a:r>
-              <a:rPr sz="1500" b="1" i="0">
+              <a:rPr sz="1500" b="1">
                 <a:solidFill>
                   <a:srgbClr val="B03A2E"/>
                 </a:solidFill>
@@ -10876,7 +10870,7 @@
           <a:p>
             <a:pPr algn="l"/>
             <a:r>
-              <a:rPr sz="900" b="0" i="0">
+              <a:rPr sz="900" b="0">
                 <a:solidFill>
                   <a:srgbClr val="71757B"/>
                 </a:solidFill>
@@ -10946,7 +10940,7 @@
           <a:p>
             <a:pPr algn="l"/>
             <a:r>
-              <a:rPr sz="800" b="0" i="0" spc="120">
+              <a:rPr sz="800" b="0" spc="120">
                 <a:solidFill>
                   <a:srgbClr val="71757B"/>
                 </a:solidFill>
@@ -10981,7 +10975,7 @@
           <a:p>
             <a:pPr algn="l"/>
             <a:r>
-              <a:rPr sz="1500" b="1" i="0">
+              <a:rPr sz="1500" b="1">
                 <a:solidFill>
                   <a:srgbClr val="1E7A4E"/>
                 </a:solidFill>
@@ -11016,13 +11010,13 @@
           <a:p>
             <a:pPr algn="l"/>
             <a:r>
-              <a:rPr sz="900" b="0" i="0">
+              <a:rPr sz="900" b="0">
                 <a:solidFill>
                   <a:srgbClr val="71757B"/>
                 </a:solidFill>
                 <a:latin typeface="Avenir Next"/>
               </a:rPr>
-              <a:t>needs a coordinated subspace</a:t>
+              <a:t>a coordinated subspace works</a:t>
             </a:r>
           </a:p>
         </p:txBody>
@@ -11086,13 +11080,13 @@
           <a:p>
             <a:pPr algn="l"/>
             <a:r>
-              <a:rPr sz="800" b="0" i="0" spc="120">
+              <a:rPr sz="800" b="0" spc="120">
                 <a:solidFill>
                   <a:srgbClr val="71757B"/>
                 </a:solidFill>
                 <a:latin typeface="Menlo"/>
               </a:rPr>
-              <a:t>LEAKAGE AT DIM 4</a:t>
+              <a:t>EITHER SCALAR, K = 1</a:t>
             </a:r>
           </a:p>
         </p:txBody>
@@ -11121,13 +11115,13 @@
           <a:p>
             <a:pPr algn="l"/>
             <a:r>
-              <a:rPr sz="1500" b="1" i="0">
-                <a:solidFill>
-                  <a:srgbClr val="1E7A4E"/>
+              <a:rPr sz="1500" b="1">
+                <a:solidFill>
+                  <a:srgbClr val="0B4F6C"/>
                 </a:solidFill>
                 <a:latin typeface="Menlo"/>
               </a:rPr>
-              <a:t>0.28×</a:t>
+              <a:t>74%</a:t>
             </a:r>
           </a:p>
         </p:txBody>
@@ -11156,13 +11150,13 @@
           <a:p>
             <a:pPr algn="l"/>
             <a:r>
-              <a:rPr sz="900" b="0" i="0">
+              <a:rPr sz="900" b="0">
                 <a:solidFill>
                   <a:srgbClr val="71757B"/>
                 </a:solidFill>
                 <a:latin typeface="Avenir Next"/>
               </a:rPr>
-              <a:t>below the probe's own noise</a:t>
+              <a:t>one probe is enough</a:t>
             </a:r>
           </a:p>
         </p:txBody>
@@ -11226,7 +11220,7 @@
           <a:p>
             <a:pPr algn="l"/>
             <a:r>
-              <a:rPr sz="800" b="0" i="0" spc="120">
+              <a:rPr sz="800" b="0" spc="120">
                 <a:solidFill>
                   <a:srgbClr val="71757B"/>
                 </a:solidFill>
@@ -11261,7 +11255,7 @@
           <a:p>
             <a:pPr algn="l"/>
             <a:r>
-              <a:rPr sz="1500" b="1" i="0">
+              <a:rPr sz="1500" b="1">
                 <a:solidFill>
                   <a:srgbClr val="B03A2E"/>
                 </a:solidFill>
@@ -11296,7 +11290,7 @@
           <a:p>
             <a:pPr algn="l"/>
             <a:r>
-              <a:rPr sz="900" b="0" i="0">
+              <a:rPr sz="900" b="0">
                 <a:solidFill>
                   <a:srgbClr val="71757B"/>
                 </a:solidFill>
@@ -11377,6 +11371,30 @@
           </a:p>
         </p:txBody>
       </p:sp>
+      <p:pic>
+        <p:nvPicPr>
+          <p:cNvPr id="26" name="Picture 25" descr="steering_combined.png"/>
+          <p:cNvPicPr>
+            <a:picLocks noChangeAspect="1"/>
+          </p:cNvPicPr>
+          <p:nvPr/>
+        </p:nvPicPr>
+        <p:blipFill>
+          <a:blip r:embed="rId4"/>
+          <a:stretch>
+            <a:fillRect/>
+          </a:stretch>
+        </p:blipFill>
+        <p:spPr>
+          <a:xfrm>
+            <a:off x="2878277" y="3042013"/>
+            <a:ext cx="6435139" cy="1880397"/>
+          </a:xfrm>
+          <a:prstGeom prst="rect">
+            <a:avLst/>
+          </a:prstGeom>
+        </p:spPr>
+      </p:pic>
     </p:spTree>
   </p:cSld>
   <p:clrMapOvr>

</xml_diff>